<commit_message>
Proje rehberi: depoyu şablondan oluştur (fork yok), projeyi yerelde göster, gösterim kontrol listesi
</commit_message>
<xml_diff>
--- a/docs/week-15/cen429-week-15-sunum.en.pptx
+++ b/docs/week-15/cen429-week-15-sunum.en.pptx
@@ -19,6 +19,7 @@
     <p:sldId id="267" r:id="rId19"/>
     <p:sldId id="268" r:id="rId20"/>
     <p:sldId id="269" r:id="rId21"/>
+    <p:sldId id="270" r:id="rId22"/>
   </p:sldIdLst>
   <p:sldSz cx="12191695" cy="6858000" type="screen4x3"/>
   <p:notesSz cx="6858000" cy="9144000"/>
@@ -3883,7 +3884,7 @@
                   <a:srgbClr val="006D77"/>
                 </a:solidFill>
               </a:rPr>
-              <a:t>Sample Questions</a:t>
+              <a:t>Demo checklist</a:t>
             </a:r>
           </a:p>
         </p:txBody>
@@ -3897,7 +3898,41 @@
         <p:spPr>
           <a:xfrm>
             <a:off x="640080" y="1325880"/>
-            <a:ext cx="10911535" cy="3337560"/>
+            <a:ext cx="10911535" cy="439928"/>
+          </a:xfrm>
+          <a:prstGeom prst="rect">
+            <a:avLst/>
+          </a:prstGeom>
+          <a:noFill/>
+        </p:spPr>
+        <p:txBody>
+          <a:bodyPr wrap="square" lIns="45720" rIns="45720">
+            <a:spAutoFit/>
+          </a:bodyPr>
+          <a:lstStyle/>
+          <a:p>
+            <a:pPr algn="l"/>
+            <a:r>
+              <a:rPr sz="2000" b="0">
+                <a:solidFill>
+                  <a:srgbClr val="1F2D3A"/>
+                </a:solidFill>
+              </a:rPr>
+              <a:t>What you open and show, in this order:</a:t>
+            </a:r>
+          </a:p>
+        </p:txBody>
+      </p:sp>
+      <p:sp>
+        <p:nvSpPr>
+          <p:cNvPr id="8" name="TextBox 7"/>
+          <p:cNvSpPr txBox="1"/>
+          <p:nvPr/>
+        </p:nvSpPr>
+        <p:spPr>
+          <a:xfrm>
+            <a:off x="640080" y="1875536"/>
+            <a:ext cx="10911535" cy="3007360"/>
           </a:xfrm>
           <a:prstGeom prst="rect">
             <a:avLst/>
@@ -3921,7 +3956,7 @@
                   <a:srgbClr val="006D77"/>
                 </a:solidFill>
               </a:rPr>
-              <a:t>• </a:t>
+              <a:t>1. </a:t>
             </a:r>
             <a:r>
               <a:rPr sz="2000" b="0">
@@ -3929,7 +3964,57 @@
                   <a:srgbClr val="1F2D3A"/>
                 </a:solidFill>
               </a:rPr>
-              <a:t>Which key is this key derived from, where does it live, when is it deleted?</a:t>
+              <a:t>The </a:t>
+            </a:r>
+            <a:r>
+              <a:rPr sz="2000" b="1">
+                <a:solidFill>
+                  <a:srgbClr val="1F2D3A"/>
+                </a:solidFill>
+              </a:rPr>
+              <a:t>home page</a:t>
+            </a:r>
+            <a:r>
+              <a:rPr sz="2000" b="0">
+                <a:solidFill>
+                  <a:srgbClr val="1F2D3A"/>
+                </a:solidFill>
+              </a:rPr>
+              <a:t> of the local site (</a:t>
+            </a:r>
+            <a:r>
+              <a:rPr sz="2000" b="0">
+                <a:solidFill>
+                  <a:srgbClr val="A1123F"/>
+                </a:solidFill>
+                <a:latin typeface="Consolas"/>
+              </a:rPr>
+              <a:t>9-open-site-...</a:t>
+            </a:r>
+            <a:r>
+              <a:rPr sz="2000" b="0">
+                <a:solidFill>
+                  <a:srgbClr val="1F2D3A"/>
+                </a:solidFill>
+              </a:rPr>
+              <a:t>, on </a:t>
+            </a:r>
+            <a:r>
+              <a:rPr sz="2000" b="0">
+                <a:solidFill>
+                  <a:srgbClr val="A1123F"/>
+                </a:solidFill>
+                <a:latin typeface="Consolas"/>
+              </a:rPr>
+              <a:t>http://localhost</a:t>
+            </a:r>
+            <a:r>
+              <a:rPr sz="2000" b="0">
+                <a:solidFill>
+                  <a:srgbClr val="1F2D3A"/>
+                </a:solidFill>
+              </a:rPr>
+              <a:t>).</a:t>
             </a:r>
           </a:p>
           <a:p>
@@ -3944,7 +4029,15 @@
                   <a:srgbClr val="006D77"/>
                 </a:solidFill>
               </a:rPr>
-              <a:t>• </a:t>
+              <a:t>2. </a:t>
+            </a:r>
+            <a:r>
+              <a:rPr sz="2000" b="1">
+                <a:solidFill>
+                  <a:srgbClr val="1F2D3A"/>
+                </a:solidFill>
+              </a:rPr>
+              <a:t>Each report page:</a:t>
             </a:r>
             <a:r>
               <a:rPr sz="2000" b="0">
@@ -3952,7 +4045,7 @@
                   <a:srgbClr val="1F2D3A"/>
                 </a:solidFill>
               </a:rPr>
-              <a:t>How do you verify the certificate chain? Where is hostname verification performed?</a:t>
+              <a:t> tests, code coverage, documentation coverage (Windows and Linux).</a:t>
             </a:r>
           </a:p>
           <a:p>
@@ -3967,7 +4060,7 @@
                   <a:srgbClr val="006D77"/>
                 </a:solidFill>
               </a:rPr>
-              <a:t>• </a:t>
+              <a:t>3. </a:t>
             </a:r>
             <a:r>
               <a:rPr sz="2000" b="0">
@@ -3975,7 +4068,23 @@
                   <a:srgbClr val="1F2D3A"/>
                 </a:solidFill>
               </a:rPr>
-              <a:t>What happens if signature verification fails? Can an old but validly signed version still be installed?</a:t>
+              <a:t>The </a:t>
+            </a:r>
+            <a:r>
+              <a:rPr sz="2000" b="1">
+                <a:solidFill>
+                  <a:srgbClr val="1F2D3A"/>
+                </a:solidFill>
+              </a:rPr>
+              <a:t>API docs</a:t>
+            </a:r>
+            <a:r>
+              <a:rPr sz="2000" b="0">
+                <a:solidFill>
+                  <a:srgbClr val="1F2D3A"/>
+                </a:solidFill>
+              </a:rPr>
+              <a:t>.</a:t>
             </a:r>
           </a:p>
           <a:p>
@@ -3990,7 +4099,7 @@
                   <a:srgbClr val="006D77"/>
                 </a:solidFill>
               </a:rPr>
-              <a:t>• </a:t>
+              <a:t>4. </a:t>
             </a:r>
             <a:r>
               <a:rPr sz="2000" b="0">
@@ -3998,7 +4107,23 @@
                   <a:srgbClr val="1F2D3A"/>
                 </a:solidFill>
               </a:rPr>
-              <a:t>Did you measure the cost of obfuscation? Which function did you obfuscate, and why?</a:t>
+              <a:t>The </a:t>
+            </a:r>
+            <a:r>
+              <a:rPr sz="2000" b="1">
+                <a:solidFill>
+                  <a:srgbClr val="1F2D3A"/>
+                </a:solidFill>
+              </a:rPr>
+              <a:t>`release/` folder</a:t>
+            </a:r>
+            <a:r>
+              <a:rPr sz="2000" b="0">
+                <a:solidFill>
+                  <a:srgbClr val="1F2D3A"/>
+                </a:solidFill>
+              </a:rPr>
+              <a:t> listing.</a:t>
             </a:r>
           </a:p>
           <a:p>
@@ -4013,7 +4138,15 @@
                   <a:srgbClr val="006D77"/>
                 </a:solidFill>
               </a:rPr>
-              <a:t>• </a:t>
+              <a:t>5. </a:t>
+            </a:r>
+            <a:r>
+              <a:rPr sz="2000" b="1">
+                <a:solidFill>
+                  <a:srgbClr val="1F2D3A"/>
+                </a:solidFill>
+              </a:rPr>
+              <a:t>Run the app</a:t>
             </a:r>
             <a:r>
               <a:rPr sz="2000" b="0">
@@ -4021,7 +4154,7 @@
                   <a:srgbClr val="1F2D3A"/>
                 </a:solidFill>
               </a:rPr>
-              <a:t>In the compliance matrix, where is the evidence for this row marked "met"?</a:t>
+              <a:t> from the release archive.</a:t>
             </a:r>
           </a:p>
           <a:p>
@@ -4036,7 +4169,7 @@
                   <a:srgbClr val="006D77"/>
                 </a:solidFill>
               </a:rPr>
-              <a:t>• </a:t>
+              <a:t>6. </a:t>
             </a:r>
             <a:r>
               <a:rPr sz="2000" b="0">
@@ -4044,7 +4177,23 @@
                   <a:srgbClr val="1F2D3A"/>
                 </a:solidFill>
               </a:rPr>
-              <a:t>Which requirement did you defer, and how will the other party meet it?</a:t>
+              <a:t>The </a:t>
+            </a:r>
+            <a:r>
+              <a:rPr sz="2000" b="1">
+                <a:solidFill>
+                  <a:srgbClr val="1F2D3A"/>
+                </a:solidFill>
+              </a:rPr>
+              <a:t>GitHub Release page</a:t>
+            </a:r>
+            <a:r>
+              <a:rPr sz="2000" b="0">
+                <a:solidFill>
+                  <a:srgbClr val="1F2D3A"/>
+                </a:solidFill>
+              </a:rPr>
+              <a:t> of your private repository (the instructor is a collaborator).</a:t>
             </a:r>
           </a:p>
         </p:txBody>
@@ -4187,6 +4336,342 @@
                 </a:solidFill>
               </a:rPr>
               <a:t>11</a:t>
+            </a:r>
+          </a:p>
+        </p:txBody>
+      </p:sp>
+      <p:sp>
+        <p:nvSpPr>
+          <p:cNvPr id="6" name="TextBox 5"/>
+          <p:cNvSpPr txBox="1"/>
+          <p:nvPr/>
+        </p:nvSpPr>
+        <p:spPr>
+          <a:xfrm>
+            <a:off x="640080" y="548640"/>
+            <a:ext cx="10911535" cy="731520"/>
+          </a:xfrm>
+          <a:prstGeom prst="rect">
+            <a:avLst/>
+          </a:prstGeom>
+          <a:noFill/>
+        </p:spPr>
+        <p:txBody>
+          <a:bodyPr wrap="square" lIns="45720" rIns="45720" anchor="ctr">
+            <a:spAutoFit/>
+          </a:bodyPr>
+          <a:lstStyle/>
+          <a:p>
+            <a:r>
+              <a:rPr sz="3000" b="1">
+                <a:solidFill>
+                  <a:srgbClr val="006D77"/>
+                </a:solidFill>
+              </a:rPr>
+              <a:t>Sample Questions</a:t>
+            </a:r>
+          </a:p>
+        </p:txBody>
+      </p:sp>
+      <p:sp>
+        <p:nvSpPr>
+          <p:cNvPr id="7" name="TextBox 6"/>
+          <p:cNvSpPr txBox="1"/>
+          <p:nvPr/>
+        </p:nvSpPr>
+        <p:spPr>
+          <a:xfrm>
+            <a:off x="640080" y="1325880"/>
+            <a:ext cx="10911535" cy="3337560"/>
+          </a:xfrm>
+          <a:prstGeom prst="rect">
+            <a:avLst/>
+          </a:prstGeom>
+          <a:noFill/>
+        </p:spPr>
+        <p:txBody>
+          <a:bodyPr wrap="square" lIns="45720" rIns="45720">
+            <a:spAutoFit/>
+          </a:bodyPr>
+          <a:lstStyle/>
+          <a:p>
+            <a:pPr>
+              <a:spcAft>
+                <a:spcPts val="300"/>
+              </a:spcAft>
+            </a:pPr>
+            <a:r>
+              <a:rPr sz="2000" b="1">
+                <a:solidFill>
+                  <a:srgbClr val="006D77"/>
+                </a:solidFill>
+              </a:rPr>
+              <a:t>• </a:t>
+            </a:r>
+            <a:r>
+              <a:rPr sz="2000" b="0">
+                <a:solidFill>
+                  <a:srgbClr val="1F2D3A"/>
+                </a:solidFill>
+              </a:rPr>
+              <a:t>Which key is this key derived from, where does it live, when is it deleted?</a:t>
+            </a:r>
+          </a:p>
+          <a:p>
+            <a:pPr>
+              <a:spcAft>
+                <a:spcPts val="300"/>
+              </a:spcAft>
+            </a:pPr>
+            <a:r>
+              <a:rPr sz="2000" b="1">
+                <a:solidFill>
+                  <a:srgbClr val="006D77"/>
+                </a:solidFill>
+              </a:rPr>
+              <a:t>• </a:t>
+            </a:r>
+            <a:r>
+              <a:rPr sz="2000" b="0">
+                <a:solidFill>
+                  <a:srgbClr val="1F2D3A"/>
+                </a:solidFill>
+              </a:rPr>
+              <a:t>How do you verify the certificate chain? Where is hostname verification performed?</a:t>
+            </a:r>
+          </a:p>
+          <a:p>
+            <a:pPr>
+              <a:spcAft>
+                <a:spcPts val="300"/>
+              </a:spcAft>
+            </a:pPr>
+            <a:r>
+              <a:rPr sz="2000" b="1">
+                <a:solidFill>
+                  <a:srgbClr val="006D77"/>
+                </a:solidFill>
+              </a:rPr>
+              <a:t>• </a:t>
+            </a:r>
+            <a:r>
+              <a:rPr sz="2000" b="0">
+                <a:solidFill>
+                  <a:srgbClr val="1F2D3A"/>
+                </a:solidFill>
+              </a:rPr>
+              <a:t>What happens if signature verification fails? Can an old but validly signed version still be installed?</a:t>
+            </a:r>
+          </a:p>
+          <a:p>
+            <a:pPr>
+              <a:spcAft>
+                <a:spcPts val="300"/>
+              </a:spcAft>
+            </a:pPr>
+            <a:r>
+              <a:rPr sz="2000" b="1">
+                <a:solidFill>
+                  <a:srgbClr val="006D77"/>
+                </a:solidFill>
+              </a:rPr>
+              <a:t>• </a:t>
+            </a:r>
+            <a:r>
+              <a:rPr sz="2000" b="0">
+                <a:solidFill>
+                  <a:srgbClr val="1F2D3A"/>
+                </a:solidFill>
+              </a:rPr>
+              <a:t>Did you measure the cost of obfuscation? Which function did you obfuscate, and why?</a:t>
+            </a:r>
+          </a:p>
+          <a:p>
+            <a:pPr>
+              <a:spcAft>
+                <a:spcPts val="300"/>
+              </a:spcAft>
+            </a:pPr>
+            <a:r>
+              <a:rPr sz="2000" b="1">
+                <a:solidFill>
+                  <a:srgbClr val="006D77"/>
+                </a:solidFill>
+              </a:rPr>
+              <a:t>• </a:t>
+            </a:r>
+            <a:r>
+              <a:rPr sz="2000" b="0">
+                <a:solidFill>
+                  <a:srgbClr val="1F2D3A"/>
+                </a:solidFill>
+              </a:rPr>
+              <a:t>In the compliance matrix, where is the evidence for this row marked "met"?</a:t>
+            </a:r>
+          </a:p>
+          <a:p>
+            <a:pPr>
+              <a:spcAft>
+                <a:spcPts val="300"/>
+              </a:spcAft>
+            </a:pPr>
+            <a:r>
+              <a:rPr sz="2000" b="1">
+                <a:solidFill>
+                  <a:srgbClr val="006D77"/>
+                </a:solidFill>
+              </a:rPr>
+              <a:t>• </a:t>
+            </a:r>
+            <a:r>
+              <a:rPr sz="2000" b="0">
+                <a:solidFill>
+                  <a:srgbClr val="1F2D3A"/>
+                </a:solidFill>
+              </a:rPr>
+              <a:t>Which requirement did you defer, and how will the other party meet it?</a:t>
+            </a:r>
+          </a:p>
+        </p:txBody>
+      </p:sp>
+    </p:spTree>
+  </p:cSld>
+  <p:clrMapOvr>
+    <a:masterClrMapping/>
+  </p:clrMapOvr>
+</p:sld>
+</file>
+
+<file path=ppt/slides/slide12.xml><?xml version="1.0" encoding="utf-8"?>
+<p:sld xmlns:a="http://schemas.openxmlformats.org/drawingml/2006/main" xmlns:p="http://schemas.openxmlformats.org/presentationml/2006/main" xmlns:r="http://schemas.openxmlformats.org/officeDocument/2006/relationships">
+  <p:cSld>
+    <p:spTree>
+      <p:nvGrpSpPr>
+        <p:cNvPr id="1" name=""/>
+        <p:cNvGrpSpPr/>
+        <p:nvPr/>
+      </p:nvGrpSpPr>
+      <p:grpSpPr/>
+      <p:pic>
+        <p:nvPicPr>
+          <p:cNvPr id="2" name="Picture 1" descr="rteu_logo_kucuk.jpg"/>
+          <p:cNvPicPr>
+            <a:picLocks noChangeAspect="1"/>
+          </p:cNvPicPr>
+          <p:nvPr/>
+        </p:nvPicPr>
+        <p:blipFill>
+          <a:blip r:embed="rId2"/>
+          <a:stretch>
+            <a:fillRect/>
+          </a:stretch>
+        </p:blipFill>
+        <p:spPr>
+          <a:xfrm>
+            <a:off x="640080" y="164592"/>
+            <a:ext cx="242773" cy="329184"/>
+          </a:xfrm>
+          <a:prstGeom prst="rect">
+            <a:avLst/>
+          </a:prstGeom>
+        </p:spPr>
+      </p:pic>
+      <p:sp>
+        <p:nvSpPr>
+          <p:cNvPr id="3" name="TextBox 2"/>
+          <p:cNvSpPr txBox="1"/>
+          <p:nvPr/>
+        </p:nvSpPr>
+        <p:spPr>
+          <a:xfrm>
+            <a:off x="1051560" y="182880"/>
+            <a:ext cx="7315200" cy="320040"/>
+          </a:xfrm>
+          <a:prstGeom prst="rect">
+            <a:avLst/>
+          </a:prstGeom>
+          <a:noFill/>
+        </p:spPr>
+        <p:txBody>
+          <a:bodyPr wrap="square" lIns="45720" rIns="45720">
+            <a:spAutoFit/>
+          </a:bodyPr>
+          <a:lstStyle/>
+          <a:p>
+            <a:r>
+              <a:rPr sz="1100" b="0">
+                <a:solidFill>
+                  <a:srgbClr val="5B6770"/>
+                </a:solidFill>
+              </a:rPr>
+              <a:t>CEN429 Secure Programming · Week 15</a:t>
+            </a:r>
+          </a:p>
+        </p:txBody>
+      </p:sp>
+      <p:sp>
+        <p:nvSpPr>
+          <p:cNvPr id="4" name="TextBox 3"/>
+          <p:cNvSpPr txBox="1"/>
+          <p:nvPr/>
+        </p:nvSpPr>
+        <p:spPr>
+          <a:xfrm>
+            <a:off x="640080" y="6446520"/>
+            <a:ext cx="7315200" cy="274320"/>
+          </a:xfrm>
+          <a:prstGeom prst="rect">
+            <a:avLst/>
+          </a:prstGeom>
+          <a:noFill/>
+        </p:spPr>
+        <p:txBody>
+          <a:bodyPr wrap="square" lIns="45720" rIns="45720">
+            <a:spAutoFit/>
+          </a:bodyPr>
+          <a:lstStyle/>
+          <a:p>
+            <a:r>
+              <a:rPr sz="1000" b="0">
+                <a:solidFill>
+                  <a:srgbClr val="5B6770"/>
+                </a:solidFill>
+              </a:rPr>
+              <a:t>RTEU Computer Engineering · 2026-2027 Fall</a:t>
+            </a:r>
+          </a:p>
+        </p:txBody>
+      </p:sp>
+      <p:sp>
+        <p:nvSpPr>
+          <p:cNvPr id="5" name="TextBox 4"/>
+          <p:cNvSpPr txBox="1"/>
+          <p:nvPr/>
+        </p:nvSpPr>
+        <p:spPr>
+          <a:xfrm>
+            <a:off x="10637215" y="6446520"/>
+            <a:ext cx="914400" cy="274320"/>
+          </a:xfrm>
+          <a:prstGeom prst="rect">
+            <a:avLst/>
+          </a:prstGeom>
+          <a:noFill/>
+        </p:spPr>
+        <p:txBody>
+          <a:bodyPr wrap="square" lIns="45720" rIns="45720">
+            <a:spAutoFit/>
+          </a:bodyPr>
+          <a:lstStyle/>
+          <a:p>
+            <a:pPr algn="r"/>
+            <a:r>
+              <a:rPr sz="1000" b="0">
+                <a:solidFill>
+                  <a:srgbClr val="5B6770"/>
+                </a:solidFill>
+              </a:rPr>
+              <a:t>12</a:t>
             </a:r>
           </a:p>
         </p:txBody>
@@ -4590,239 +5075,6 @@
 </p:sld>
 </file>
 
-<file path=ppt/slides/slide12.xml><?xml version="1.0" encoding="utf-8"?>
-<p:sld xmlns:a="http://schemas.openxmlformats.org/drawingml/2006/main" xmlns:p="http://schemas.openxmlformats.org/presentationml/2006/main" xmlns:r="http://schemas.openxmlformats.org/officeDocument/2006/relationships">
-  <p:cSld>
-    <p:spTree>
-      <p:nvGrpSpPr>
-        <p:cNvPr id="1" name=""/>
-        <p:cNvGrpSpPr/>
-        <p:nvPr/>
-      </p:nvGrpSpPr>
-      <p:grpSpPr/>
-      <p:pic>
-        <p:nvPicPr>
-          <p:cNvPr id="2" name="Picture 1" descr="rteu_logo_kucuk.jpg"/>
-          <p:cNvPicPr>
-            <a:picLocks noChangeAspect="1"/>
-          </p:cNvPicPr>
-          <p:nvPr/>
-        </p:nvPicPr>
-        <p:blipFill>
-          <a:blip r:embed="rId2"/>
-          <a:stretch>
-            <a:fillRect/>
-          </a:stretch>
-        </p:blipFill>
-        <p:spPr>
-          <a:xfrm>
-            <a:off x="640080" y="164592"/>
-            <a:ext cx="242773" cy="329184"/>
-          </a:xfrm>
-          <a:prstGeom prst="rect">
-            <a:avLst/>
-          </a:prstGeom>
-        </p:spPr>
-      </p:pic>
-      <p:sp>
-        <p:nvSpPr>
-          <p:cNvPr id="3" name="TextBox 2"/>
-          <p:cNvSpPr txBox="1"/>
-          <p:nvPr/>
-        </p:nvSpPr>
-        <p:spPr>
-          <a:xfrm>
-            <a:off x="1051560" y="182880"/>
-            <a:ext cx="7315200" cy="320040"/>
-          </a:xfrm>
-          <a:prstGeom prst="rect">
-            <a:avLst/>
-          </a:prstGeom>
-          <a:noFill/>
-        </p:spPr>
-        <p:txBody>
-          <a:bodyPr wrap="square" lIns="45720" rIns="45720">
-            <a:spAutoFit/>
-          </a:bodyPr>
-          <a:lstStyle/>
-          <a:p>
-            <a:r>
-              <a:rPr sz="1100" b="0">
-                <a:solidFill>
-                  <a:srgbClr val="5B6770"/>
-                </a:solidFill>
-              </a:rPr>
-              <a:t>CEN429 Secure Programming · Week 15</a:t>
-            </a:r>
-          </a:p>
-        </p:txBody>
-      </p:sp>
-      <p:sp>
-        <p:nvSpPr>
-          <p:cNvPr id="4" name="TextBox 3"/>
-          <p:cNvSpPr txBox="1"/>
-          <p:nvPr/>
-        </p:nvSpPr>
-        <p:spPr>
-          <a:xfrm>
-            <a:off x="640080" y="6446520"/>
-            <a:ext cx="7315200" cy="274320"/>
-          </a:xfrm>
-          <a:prstGeom prst="rect">
-            <a:avLst/>
-          </a:prstGeom>
-          <a:noFill/>
-        </p:spPr>
-        <p:txBody>
-          <a:bodyPr wrap="square" lIns="45720" rIns="45720">
-            <a:spAutoFit/>
-          </a:bodyPr>
-          <a:lstStyle/>
-          <a:p>
-            <a:r>
-              <a:rPr sz="1000" b="0">
-                <a:solidFill>
-                  <a:srgbClr val="5B6770"/>
-                </a:solidFill>
-              </a:rPr>
-              <a:t>RTEU Computer Engineering · 2026-2027 Fall</a:t>
-            </a:r>
-          </a:p>
-        </p:txBody>
-      </p:sp>
-      <p:sp>
-        <p:nvSpPr>
-          <p:cNvPr id="5" name="TextBox 4"/>
-          <p:cNvSpPr txBox="1"/>
-          <p:nvPr/>
-        </p:nvSpPr>
-        <p:spPr>
-          <a:xfrm>
-            <a:off x="10637215" y="6446520"/>
-            <a:ext cx="914400" cy="274320"/>
-          </a:xfrm>
-          <a:prstGeom prst="rect">
-            <a:avLst/>
-          </a:prstGeom>
-          <a:noFill/>
-        </p:spPr>
-        <p:txBody>
-          <a:bodyPr wrap="square" lIns="45720" rIns="45720">
-            <a:spAutoFit/>
-          </a:bodyPr>
-          <a:lstStyle/>
-          <a:p>
-            <a:pPr algn="r"/>
-            <a:r>
-              <a:rPr sz="1000" b="0">
-                <a:solidFill>
-                  <a:srgbClr val="5B6770"/>
-                </a:solidFill>
-              </a:rPr>
-              <a:t>12</a:t>
-            </a:r>
-          </a:p>
-        </p:txBody>
-      </p:sp>
-      <p:sp>
-        <p:nvSpPr>
-          <p:cNvPr id="6" name="TextBox 5"/>
-          <p:cNvSpPr txBox="1"/>
-          <p:nvPr/>
-        </p:nvSpPr>
-        <p:spPr>
-          <a:xfrm>
-            <a:off x="640080" y="548640"/>
-            <a:ext cx="10911535" cy="731520"/>
-          </a:xfrm>
-          <a:prstGeom prst="rect">
-            <a:avLst/>
-          </a:prstGeom>
-          <a:noFill/>
-        </p:spPr>
-        <p:txBody>
-          <a:bodyPr wrap="square" lIns="45720" rIns="45720" anchor="ctr">
-            <a:spAutoFit/>
-          </a:bodyPr>
-          <a:lstStyle/>
-          <a:p>
-            <a:r>
-              <a:rPr sz="3000" b="1">
-                <a:solidFill>
-                  <a:srgbClr val="006D77"/>
-                </a:solidFill>
-              </a:rPr>
-              <a:t>Academic Integrity</a:t>
-            </a:r>
-          </a:p>
-        </p:txBody>
-      </p:sp>
-      <p:sp>
-        <p:nvSpPr>
-          <p:cNvPr id="7" name="TextBox 6"/>
-          <p:cNvSpPr txBox="1"/>
-          <p:nvPr/>
-        </p:nvSpPr>
-        <p:spPr>
-          <a:xfrm>
-            <a:off x="640080" y="1325880"/>
-            <a:ext cx="10911535" cy="1100327"/>
-          </a:xfrm>
-          <a:prstGeom prst="rect">
-            <a:avLst/>
-          </a:prstGeom>
-          <a:noFill/>
-        </p:spPr>
-        <p:txBody>
-          <a:bodyPr wrap="square" lIns="45720" rIns="45720">
-            <a:spAutoFit/>
-          </a:bodyPr>
-          <a:lstStyle/>
-          <a:p>
-            <a:pPr algn="l"/>
-            <a:r>
-              <a:rPr sz="2000" b="0">
-                <a:solidFill>
-                  <a:srgbClr val="1F2D3A"/>
-                </a:solidFill>
-              </a:rPr>
-              <a:t>The syllabus's "Academic Integrity" section also applies to the project; every submitted line must be explainable, and any team member may be asked a question during the demonstration.</a:t>
-            </a:r>
-          </a:p>
-        </p:txBody>
-      </p:sp>
-      <p:pic>
-        <p:nvPicPr>
-          <p:cNvPr id="8" name="Picture 7" descr="h15-04-s16.png"/>
-          <p:cNvPicPr>
-            <a:picLocks noChangeAspect="1"/>
-          </p:cNvPicPr>
-          <p:nvPr/>
-        </p:nvPicPr>
-        <p:blipFill>
-          <a:blip r:embed="rId3"/>
-          <a:stretch>
-            <a:fillRect/>
-          </a:stretch>
-        </p:blipFill>
-        <p:spPr>
-          <a:xfrm>
-            <a:off x="1477007" y="2535936"/>
-            <a:ext cx="9237681" cy="3617976"/>
-          </a:xfrm>
-          <a:prstGeom prst="rect">
-            <a:avLst/>
-          </a:prstGeom>
-        </p:spPr>
-      </p:pic>
-    </p:spTree>
-  </p:cSld>
-  <p:clrMapOvr>
-    <a:masterClrMapping/>
-  </p:clrMapOvr>
-</p:sld>
-</file>
-
 <file path=ppt/slides/slide13.xml><?xml version="1.0" encoding="utf-8"?>
 <p:sld xmlns:a="http://schemas.openxmlformats.org/drawingml/2006/main" xmlns:p="http://schemas.openxmlformats.org/presentationml/2006/main" xmlns:r="http://schemas.openxmlformats.org/officeDocument/2006/relationships">
   <p:cSld>
@@ -4985,7 +5237,7 @@
                   <a:srgbClr val="006D77"/>
                 </a:solidFill>
               </a:rPr>
-              <a:t>At the End of the Term</a:t>
+              <a:t>Academic Integrity</a:t>
             </a:r>
           </a:p>
         </p:txBody>
@@ -4999,7 +5251,7 @@
         <p:spPr>
           <a:xfrm>
             <a:off x="640080" y="1325880"/>
-            <a:ext cx="10911535" cy="797560"/>
+            <a:ext cx="10911535" cy="1100327"/>
           </a:xfrm>
           <a:prstGeom prst="rect">
             <a:avLst/>
@@ -5012,115 +5264,42 @@
           </a:bodyPr>
           <a:lstStyle/>
           <a:p>
-            <a:pPr>
-              <a:spcAft>
-                <a:spcPts val="300"/>
-              </a:spcAft>
-            </a:pPr>
-            <a:r>
-              <a:rPr sz="2000" b="1">
-                <a:solidFill>
-                  <a:srgbClr val="006D77"/>
-                </a:solidFill>
-              </a:rPr>
-              <a:t>• </a:t>
-            </a:r>
+            <a:pPr algn="l"/>
             <a:r>
               <a:rPr sz="2000" b="0">
                 <a:solidFill>
                   <a:srgbClr val="1F2D3A"/>
                 </a:solidFill>
               </a:rPr>
-              <a:t>Your guide = a small model of certification documents → </a:t>
-            </a:r>
-            <a:r>
-              <a:rPr sz="2000" b="1">
-                <a:solidFill>
-                  <a:srgbClr val="1F2D3A"/>
-                </a:solidFill>
-              </a:rPr>
-              <a:t>portfolio</a:t>
-            </a:r>
-            <a:r>
-              <a:rPr sz="2000" b="0">
-                <a:solidFill>
-                  <a:srgbClr val="1F2D3A"/>
-                </a:solidFill>
-              </a:rPr>
-              <a:t> (make sure it contains no confidential information)</a:t>
-            </a:r>
-          </a:p>
-        </p:txBody>
-      </p:sp>
-      <p:sp>
-        <p:nvSpPr>
-          <p:cNvPr id="8" name="Rectangle 7"/>
-          <p:cNvSpPr/>
+              <a:t>The syllabus's "Academic Integrity" section also applies to the project; every submitted line must be explainable, and any team member may be asked a question during the demonstration.</a:t>
+            </a:r>
+          </a:p>
+        </p:txBody>
+      </p:sp>
+      <p:pic>
+        <p:nvPicPr>
+          <p:cNvPr id="8" name="Picture 7" descr="h15-04-s16.png"/>
+          <p:cNvPicPr>
+            <a:picLocks noChangeAspect="1"/>
+          </p:cNvPicPr>
           <p:nvPr/>
-        </p:nvSpPr>
-        <p:spPr>
-          <a:xfrm>
-            <a:off x="640080" y="2233168"/>
-            <a:ext cx="10911535" cy="934719"/>
-          </a:xfrm>
-          <a:prstGeom prst="rect">
-            <a:avLst/>
-          </a:prstGeom>
-          <a:solidFill>
-            <a:srgbClr val="EEF7F8"/>
-          </a:solidFill>
-          <a:ln>
-            <a:solidFill>
-              <a:srgbClr val="006D77"/>
-            </a:solidFill>
-          </a:ln>
-        </p:spPr>
-        <p:style>
-          <a:lnRef idx="1">
-            <a:schemeClr val="accent1"/>
-          </a:lnRef>
-          <a:fillRef idx="3">
-            <a:schemeClr val="accent1"/>
-          </a:fillRef>
-          <a:effectRef idx="2">
-            <a:schemeClr val="accent1"/>
-          </a:effectRef>
-          <a:fontRef idx="minor">
-            <a:schemeClr val="lt1"/>
-          </a:fontRef>
-        </p:style>
-        <p:txBody>
-          <a:bodyPr rtlCol="0" anchor="ctr" wrap="square" lIns="182880"/>
-          <a:lstStyle/>
-          <a:p>
-            <a:pPr algn="l"/>
-            <a:r>
-              <a:rPr sz="2000" b="0">
-                <a:solidFill>
-                  <a:srgbClr val="1F2D3A"/>
-                </a:solidFill>
-              </a:rPr>
-              <a:t>At the final, </a:t>
-            </a:r>
-            <a:r>
-              <a:rPr sz="2000" b="1">
-                <a:solidFill>
-                  <a:srgbClr val="1F2D3A"/>
-                </a:solidFill>
-              </a:rPr>
-              <a:t>results</a:t>
-            </a:r>
-            <a:r>
-              <a:rPr sz="2000" b="0">
-                <a:solidFill>
-                  <a:srgbClr val="1F2D3A"/>
-                </a:solidFill>
-              </a:rPr>
-              <a:t> are expected: every protection is shown working, every requirement is tied to evidence.</a:t>
-            </a:r>
-          </a:p>
-        </p:txBody>
-      </p:sp>
+        </p:nvPicPr>
+        <p:blipFill>
+          <a:blip r:embed="rId3"/>
+          <a:stretch>
+            <a:fillRect/>
+          </a:stretch>
+        </p:blipFill>
+        <p:spPr>
+          <a:xfrm>
+            <a:off x="1477007" y="2535936"/>
+            <a:ext cx="9237681" cy="3617976"/>
+          </a:xfrm>
+          <a:prstGeom prst="rect">
+            <a:avLst/>
+          </a:prstGeom>
+        </p:spPr>
+      </p:pic>
     </p:spTree>
   </p:cSld>
   <p:clrMapOvr>
@@ -5259,6 +5438,312 @@
                 </a:solidFill>
               </a:rPr>
               <a:t>14</a:t>
+            </a:r>
+          </a:p>
+        </p:txBody>
+      </p:sp>
+      <p:sp>
+        <p:nvSpPr>
+          <p:cNvPr id="6" name="TextBox 5"/>
+          <p:cNvSpPr txBox="1"/>
+          <p:nvPr/>
+        </p:nvSpPr>
+        <p:spPr>
+          <a:xfrm>
+            <a:off x="640080" y="548640"/>
+            <a:ext cx="10911535" cy="731520"/>
+          </a:xfrm>
+          <a:prstGeom prst="rect">
+            <a:avLst/>
+          </a:prstGeom>
+          <a:noFill/>
+        </p:spPr>
+        <p:txBody>
+          <a:bodyPr wrap="square" lIns="45720" rIns="45720" anchor="ctr">
+            <a:spAutoFit/>
+          </a:bodyPr>
+          <a:lstStyle/>
+          <a:p>
+            <a:r>
+              <a:rPr sz="3000" b="1">
+                <a:solidFill>
+                  <a:srgbClr val="006D77"/>
+                </a:solidFill>
+              </a:rPr>
+              <a:t>At the End of the Term</a:t>
+            </a:r>
+          </a:p>
+        </p:txBody>
+      </p:sp>
+      <p:sp>
+        <p:nvSpPr>
+          <p:cNvPr id="7" name="TextBox 6"/>
+          <p:cNvSpPr txBox="1"/>
+          <p:nvPr/>
+        </p:nvSpPr>
+        <p:spPr>
+          <a:xfrm>
+            <a:off x="640080" y="1325880"/>
+            <a:ext cx="10911535" cy="797560"/>
+          </a:xfrm>
+          <a:prstGeom prst="rect">
+            <a:avLst/>
+          </a:prstGeom>
+          <a:noFill/>
+        </p:spPr>
+        <p:txBody>
+          <a:bodyPr wrap="square" lIns="45720" rIns="45720">
+            <a:spAutoFit/>
+          </a:bodyPr>
+          <a:lstStyle/>
+          <a:p>
+            <a:pPr>
+              <a:spcAft>
+                <a:spcPts val="300"/>
+              </a:spcAft>
+            </a:pPr>
+            <a:r>
+              <a:rPr sz="2000" b="1">
+                <a:solidFill>
+                  <a:srgbClr val="006D77"/>
+                </a:solidFill>
+              </a:rPr>
+              <a:t>• </a:t>
+            </a:r>
+            <a:r>
+              <a:rPr sz="2000" b="0">
+                <a:solidFill>
+                  <a:srgbClr val="1F2D3A"/>
+                </a:solidFill>
+              </a:rPr>
+              <a:t>Your guide = a small model of certification documents → </a:t>
+            </a:r>
+            <a:r>
+              <a:rPr sz="2000" b="1">
+                <a:solidFill>
+                  <a:srgbClr val="1F2D3A"/>
+                </a:solidFill>
+              </a:rPr>
+              <a:t>portfolio</a:t>
+            </a:r>
+            <a:r>
+              <a:rPr sz="2000" b="0">
+                <a:solidFill>
+                  <a:srgbClr val="1F2D3A"/>
+                </a:solidFill>
+              </a:rPr>
+              <a:t> (make sure it contains no confidential information)</a:t>
+            </a:r>
+          </a:p>
+        </p:txBody>
+      </p:sp>
+      <p:sp>
+        <p:nvSpPr>
+          <p:cNvPr id="8" name="Rectangle 7"/>
+          <p:cNvSpPr/>
+          <p:nvPr/>
+        </p:nvSpPr>
+        <p:spPr>
+          <a:xfrm>
+            <a:off x="640080" y="2233168"/>
+            <a:ext cx="10911535" cy="934719"/>
+          </a:xfrm>
+          <a:prstGeom prst="rect">
+            <a:avLst/>
+          </a:prstGeom>
+          <a:solidFill>
+            <a:srgbClr val="EEF7F8"/>
+          </a:solidFill>
+          <a:ln>
+            <a:solidFill>
+              <a:srgbClr val="006D77"/>
+            </a:solidFill>
+          </a:ln>
+        </p:spPr>
+        <p:style>
+          <a:lnRef idx="1">
+            <a:schemeClr val="accent1"/>
+          </a:lnRef>
+          <a:fillRef idx="3">
+            <a:schemeClr val="accent1"/>
+          </a:fillRef>
+          <a:effectRef idx="2">
+            <a:schemeClr val="accent1"/>
+          </a:effectRef>
+          <a:fontRef idx="minor">
+            <a:schemeClr val="lt1"/>
+          </a:fontRef>
+        </p:style>
+        <p:txBody>
+          <a:bodyPr rtlCol="0" anchor="ctr" wrap="square" lIns="182880"/>
+          <a:lstStyle/>
+          <a:p>
+            <a:pPr algn="l"/>
+            <a:r>
+              <a:rPr sz="2000" b="0">
+                <a:solidFill>
+                  <a:srgbClr val="1F2D3A"/>
+                </a:solidFill>
+              </a:rPr>
+              <a:t>At the final, </a:t>
+            </a:r>
+            <a:r>
+              <a:rPr sz="2000" b="1">
+                <a:solidFill>
+                  <a:srgbClr val="1F2D3A"/>
+                </a:solidFill>
+              </a:rPr>
+              <a:t>results</a:t>
+            </a:r>
+            <a:r>
+              <a:rPr sz="2000" b="0">
+                <a:solidFill>
+                  <a:srgbClr val="1F2D3A"/>
+                </a:solidFill>
+              </a:rPr>
+              <a:t> are expected: every protection is shown working, every requirement is tied to evidence.</a:t>
+            </a:r>
+          </a:p>
+        </p:txBody>
+      </p:sp>
+    </p:spTree>
+  </p:cSld>
+  <p:clrMapOvr>
+    <a:masterClrMapping/>
+  </p:clrMapOvr>
+</p:sld>
+</file>
+
+<file path=ppt/slides/slide15.xml><?xml version="1.0" encoding="utf-8"?>
+<p:sld xmlns:a="http://schemas.openxmlformats.org/drawingml/2006/main" xmlns:p="http://schemas.openxmlformats.org/presentationml/2006/main" xmlns:r="http://schemas.openxmlformats.org/officeDocument/2006/relationships">
+  <p:cSld>
+    <p:spTree>
+      <p:nvGrpSpPr>
+        <p:cNvPr id="1" name=""/>
+        <p:cNvGrpSpPr/>
+        <p:nvPr/>
+      </p:nvGrpSpPr>
+      <p:grpSpPr/>
+      <p:pic>
+        <p:nvPicPr>
+          <p:cNvPr id="2" name="Picture 1" descr="rteu_logo_kucuk.jpg"/>
+          <p:cNvPicPr>
+            <a:picLocks noChangeAspect="1"/>
+          </p:cNvPicPr>
+          <p:nvPr/>
+        </p:nvPicPr>
+        <p:blipFill>
+          <a:blip r:embed="rId2"/>
+          <a:stretch>
+            <a:fillRect/>
+          </a:stretch>
+        </p:blipFill>
+        <p:spPr>
+          <a:xfrm>
+            <a:off x="640080" y="164592"/>
+            <a:ext cx="242773" cy="329184"/>
+          </a:xfrm>
+          <a:prstGeom prst="rect">
+            <a:avLst/>
+          </a:prstGeom>
+        </p:spPr>
+      </p:pic>
+      <p:sp>
+        <p:nvSpPr>
+          <p:cNvPr id="3" name="TextBox 2"/>
+          <p:cNvSpPr txBox="1"/>
+          <p:nvPr/>
+        </p:nvSpPr>
+        <p:spPr>
+          <a:xfrm>
+            <a:off x="1051560" y="182880"/>
+            <a:ext cx="7315200" cy="320040"/>
+          </a:xfrm>
+          <a:prstGeom prst="rect">
+            <a:avLst/>
+          </a:prstGeom>
+          <a:noFill/>
+        </p:spPr>
+        <p:txBody>
+          <a:bodyPr wrap="square" lIns="45720" rIns="45720">
+            <a:spAutoFit/>
+          </a:bodyPr>
+          <a:lstStyle/>
+          <a:p>
+            <a:r>
+              <a:rPr sz="1100" b="0">
+                <a:solidFill>
+                  <a:srgbClr val="5B6770"/>
+                </a:solidFill>
+              </a:rPr>
+              <a:t>CEN429 Secure Programming · Week 15</a:t>
+            </a:r>
+          </a:p>
+        </p:txBody>
+      </p:sp>
+      <p:sp>
+        <p:nvSpPr>
+          <p:cNvPr id="4" name="TextBox 3"/>
+          <p:cNvSpPr txBox="1"/>
+          <p:nvPr/>
+        </p:nvSpPr>
+        <p:spPr>
+          <a:xfrm>
+            <a:off x="640080" y="6446520"/>
+            <a:ext cx="7315200" cy="274320"/>
+          </a:xfrm>
+          <a:prstGeom prst="rect">
+            <a:avLst/>
+          </a:prstGeom>
+          <a:noFill/>
+        </p:spPr>
+        <p:txBody>
+          <a:bodyPr wrap="square" lIns="45720" rIns="45720">
+            <a:spAutoFit/>
+          </a:bodyPr>
+          <a:lstStyle/>
+          <a:p>
+            <a:r>
+              <a:rPr sz="1000" b="0">
+                <a:solidFill>
+                  <a:srgbClr val="5B6770"/>
+                </a:solidFill>
+              </a:rPr>
+              <a:t>RTEU Computer Engineering · 2026-2027 Fall</a:t>
+            </a:r>
+          </a:p>
+        </p:txBody>
+      </p:sp>
+      <p:sp>
+        <p:nvSpPr>
+          <p:cNvPr id="5" name="TextBox 4"/>
+          <p:cNvSpPr txBox="1"/>
+          <p:nvPr/>
+        </p:nvSpPr>
+        <p:spPr>
+          <a:xfrm>
+            <a:off x="10637215" y="6446520"/>
+            <a:ext cx="914400" cy="274320"/>
+          </a:xfrm>
+          <a:prstGeom prst="rect">
+            <a:avLst/>
+          </a:prstGeom>
+          <a:noFill/>
+        </p:spPr>
+        <p:txBody>
+          <a:bodyPr wrap="square" lIns="45720" rIns="45720">
+            <a:spAutoFit/>
+          </a:bodyPr>
+          <a:lstStyle/>
+          <a:p>
+            <a:pPr algn="r"/>
+            <a:r>
+              <a:rPr sz="1000" b="0">
+                <a:solidFill>
+                  <a:srgbClr val="5B6770"/>
+                </a:solidFill>
+              </a:rPr>
+              <a:t>15</a:t>
             </a:r>
           </a:p>
         </p:txBody>

</xml_diff>